<commit_message>
fit: correção dos nomes
</commit_message>
<xml_diff>
--- a/presentation/Weather_Prediction_Macau_Slides.pptx
+++ b/presentation/Weather_Prediction_Macau_Slides.pptx
@@ -117,17 +117,17 @@
   <p:extLst>
     <p:ext uri="{521415D9-36F7-43E2-AB2F-B90AF26B5E84}">
       <p14:sectionLst xmlns:p14="http://schemas.microsoft.com/office/powerpoint/2010/main">
-        <p14:section name="Introduction" id="{5efad1c8-6739-ab23-016a-f9a1d5d8663c}">
+        <p14:section name="Introduction" id="{75b07c88-a90d-c3fe-9b43-0cd16d92404f}">
           <p14:sldIdLst>
             <p14:sldId id="256"/>
           </p14:sldIdLst>
         </p14:section>
-        <p14:section name="Problem and data" id="{07912616-9cc9-34d4-6475-bc6a0db39627}">
+        <p14:section name="Problem and data" id="{abbca7b5-f5b5-4f17-e2c3-71c78b86ab87}">
           <p14:sldIdLst>
             <p14:sldId id="257"/>
           </p14:sldIdLst>
         </p14:section>
-        <p14:section name="Method" id="{b7145e2a-6dba-0e91-61e8-a862738c2df6}">
+        <p14:section name="Method" id="{a2b517e6-b203-c1d2-f6b2-7b775ba7f82c}">
           <p14:sldIdLst>
             <p14:sldId id="258"/>
             <p14:sldId id="259"/>
@@ -135,14 +135,14 @@
             <p14:sldId id="261"/>
           </p14:sldIdLst>
         </p14:section>
-        <p14:section name="Results" id="{f444e39f-6dc7-7d41-bfe8-f4a38b835935}">
+        <p14:section name="Results" id="{54eeac94-1e0a-efe8-00a5-0bd186041c9c}">
           <p14:sldIdLst>
             <p14:sldId id="262"/>
             <p14:sldId id="263"/>
             <p14:sldId id="264"/>
           </p14:sldIdLst>
         </p14:section>
-        <p14:section name="Discussion" id="{7526eb69-10ed-61a6-fa97-f5a73c28dd35}">
+        <p14:section name="Discussion" id="{3689c160-f468-e986-70af-67c14c3fa17f}">
           <p14:sldIdLst>
             <p14:sldId id="265"/>
             <p14:sldId id="266"/>
@@ -2251,7 +2251,7 @@
         <p:spPr>
           <a:xfrm>
             <a:off x="640080" y="4206240"/>
-            <a:ext cx="5943600" cy="274320"/>
+            <a:ext cx="7863840" cy="274320"/>
           </a:xfrm>
           <a:prstGeom prst="rect">
             <a:avLst/>
@@ -2272,7 +2272,7 @@
                   <a:srgbClr val="FFFFFF"/>
                 </a:solidFill>
               </a:rPr>
-              <a:t>Thiago Honorato Ferreira  ·  Marcelo Oliveira  ·  João Vitor Konrad</a:t>
+              <a:t>Thiago Honorato Ferreira  ·  Marcelo Oliveira Volpato  ·  João Vitor Konrad</a:t>
             </a:r>
             <a:endParaRPr lang="en-US" sz="1300" dirty="0"/>
           </a:p>

</xml_diff>